<commit_message>
docs: replace poster with 8-page Swiss-style deck (16:9 hi-res)
</commit_message>
<xml_diff>
--- a/Knowledge-Garden/docs/poster/Knowledge-Garden.pptx
+++ b/Knowledge-Garden/docs/poster/Knowledge-Garden.pptx
@@ -10,6 +10,9 @@
     <p:sldId id="258" r:id="rId9"/>
     <p:sldId id="259" r:id="rId10"/>
     <p:sldId id="260" r:id="rId11"/>
+    <p:sldId id="261" r:id="rId12"/>
+    <p:sldId id="262" r:id="rId13"/>
+    <p:sldId id="263" r:id="rId14"/>
   </p:sldIdLst>
   <p:sldSz cx="12191695" cy="6858000" type="screen4x3"/>
   <p:notesSz cx="6858000" cy="9144000"/>
@@ -3092,68 +3095,30 @@
         <p:nvPr/>
       </p:nvGrpSpPr>
       <p:grpSpPr/>
-      <p:sp>
-        <p:nvSpPr>
-          <p:cNvPr id="2" name="TextBox 1"/>
-          <p:cNvSpPr txBox="1"/>
+      <p:pic>
+        <p:nvPicPr>
+          <p:cNvPr id="2" name="Picture 1" descr="slide-1.png"/>
+          <p:cNvPicPr>
+            <a:picLocks noChangeAspect="1"/>
+          </p:cNvPicPr>
           <p:nvPr/>
-        </p:nvSpPr>
+        </p:nvPicPr>
+        <p:blipFill>
+          <a:blip r:embed="rId2"/>
+          <a:stretch>
+            <a:fillRect/>
+          </a:stretch>
+        </p:blipFill>
         <p:spPr>
           <a:xfrm>
-            <a:off x="914400" y="1828800"/>
-            <a:ext cx="10332720" cy="3200400"/>
+            <a:off x="0" y="0"/>
+            <a:ext cx="12191695" cy="6858000"/>
           </a:xfrm>
           <a:prstGeom prst="rect">
             <a:avLst/>
           </a:prstGeom>
-          <a:noFill/>
         </p:spPr>
-        <p:txBody>
-          <a:bodyPr wrap="square">
-            <a:spAutoFit/>
-          </a:bodyPr>
-          <a:lstStyle/>
-          <a:p>
-            <a:r>
-              <a:rPr sz="6000" b="1"/>
-              <a:t>Knowledge Garden</a:t>
-            </a:r>
-          </a:p>
-          <a:p>
-            <a:pPr>
-              <a:spcAft>
-                <a:spcPts val="800"/>
-              </a:spcAft>
-              <a:defRPr sz="2400"/>
-            </a:pPr>
-            <a:r>
-              <a:t>A Private Learning Companion Agent on AMD Radeon</a:t>
-            </a:r>
-          </a:p>
-          <a:p>
-            <a:pPr>
-              <a:spcAft>
-                <a:spcPts val="800"/>
-              </a:spcAft>
-              <a:defRPr sz="2400"/>
-            </a:pPr>
-            <a:r>
-              <a:t>Track 2 — Development &amp; Local Deployment of Private AI Agents</a:t>
-            </a:r>
-          </a:p>
-          <a:p>
-            <a:pPr>
-              <a:spcAft>
-                <a:spcPts val="800"/>
-              </a:spcAft>
-              <a:defRPr sz="2400"/>
-            </a:pPr>
-            <a:r>
-              <a:t>maoshaoyang · AMD AI DevMaster Hackathon 2026-07</a:t>
-            </a:r>
-          </a:p>
-        </p:txBody>
-      </p:sp>
+      </p:pic>
     </p:spTree>
   </p:cSld>
   <p:clrMapOvr>
@@ -3172,101 +3137,30 @@
         <p:nvPr/>
       </p:nvGrpSpPr>
       <p:grpSpPr/>
-      <p:sp>
-        <p:nvSpPr>
-          <p:cNvPr id="2" name="TextBox 1"/>
-          <p:cNvSpPr txBox="1"/>
+      <p:pic>
+        <p:nvPicPr>
+          <p:cNvPr id="2" name="Picture 1" descr="slide-2.png"/>
+          <p:cNvPicPr>
+            <a:picLocks noChangeAspect="1"/>
+          </p:cNvPicPr>
           <p:nvPr/>
-        </p:nvSpPr>
+        </p:nvPicPr>
+        <p:blipFill>
+          <a:blip r:embed="rId2"/>
+          <a:stretch>
+            <a:fillRect/>
+          </a:stretch>
+        </p:blipFill>
         <p:spPr>
           <a:xfrm>
-            <a:off x="548640" y="365760"/>
-            <a:ext cx="11064240" cy="6035040"/>
+            <a:off x="0" y="0"/>
+            <a:ext cx="12191695" cy="6858000"/>
           </a:xfrm>
           <a:prstGeom prst="rect">
             <a:avLst/>
           </a:prstGeom>
-          <a:noFill/>
         </p:spPr>
-        <p:txBody>
-          <a:bodyPr wrap="square">
-            <a:spAutoFit/>
-          </a:bodyPr>
-          <a:lstStyle/>
-          <a:p>
-            <a:r>
-              <a:rPr sz="4000" b="1"/>
-              <a:t>Core Capabilities</a:t>
-            </a:r>
-          </a:p>
-          <a:p>
-            <a:pPr>
-              <a:spcAft>
-                <a:spcPts val="1000"/>
-              </a:spcAft>
-              <a:defRPr sz="2000"/>
-            </a:pPr>
-            <a:r>
-              <a:t>Markdown-only upload with original-source persistence</a:t>
-            </a:r>
-          </a:p>
-          <a:p>
-            <a:pPr>
-              <a:spcAft>
-                <a:spcPts val="1000"/>
-              </a:spcAft>
-              <a:defRPr sz="2000"/>
-            </a:pPr>
-            <a:r>
-              <a:t>Verified knowledge extraction (32B model + source validation)</a:t>
-            </a:r>
-          </a:p>
-          <a:p>
-            <a:pPr>
-              <a:spcAft>
-                <a:spcPts val="1000"/>
-              </a:spcAft>
-              <a:defRPr sz="2000"/>
-            </a:pPr>
-            <a:r>
-              <a:t>Feynman recall learning with structured feedback</a:t>
-            </a:r>
-          </a:p>
-          <a:p>
-            <a:pPr>
-              <a:spcAft>
-                <a:spcPts val="1000"/>
-              </a:spcAft>
-              <a:defRPr sz="2000"/>
-            </a:pPr>
-            <a:r>
-              <a:t>Mastery assessment with server-side grading</a:t>
-            </a:r>
-          </a:p>
-          <a:p>
-            <a:pPr>
-              <a:spcAft>
-                <a:spcPts val="1000"/>
-              </a:spcAft>
-              <a:defRPr sz="2000"/>
-            </a:pPr>
-            <a:r>
-              <a:t>SM-2 spaced repetition on the Ebbinghaus forgetting curve</a:t>
-            </a:r>
-          </a:p>
-          <a:p>
-            <a:pPr>
-              <a:spcAft>
-                <a:spcPts val="1000"/>
-              </a:spcAft>
-              <a:defRPr sz="2000"/>
-            </a:pPr>
-            <a:r>
-              <a:t>Full source traceability — every unit links to its document</a:t>
-            </a:r>
-          </a:p>
-        </p:txBody>
-      </p:sp>
+      </p:pic>
     </p:spTree>
   </p:cSld>
   <p:clrMapOvr>
@@ -3285,90 +3179,30 @@
         <p:nvPr/>
       </p:nvGrpSpPr>
       <p:grpSpPr/>
-      <p:sp>
-        <p:nvSpPr>
-          <p:cNvPr id="2" name="TextBox 1"/>
-          <p:cNvSpPr txBox="1"/>
+      <p:pic>
+        <p:nvPicPr>
+          <p:cNvPr id="2" name="Picture 1" descr="slide-3.png"/>
+          <p:cNvPicPr>
+            <a:picLocks noChangeAspect="1"/>
+          </p:cNvPicPr>
           <p:nvPr/>
-        </p:nvSpPr>
+        </p:nvPicPr>
+        <p:blipFill>
+          <a:blip r:embed="rId2"/>
+          <a:stretch>
+            <a:fillRect/>
+          </a:stretch>
+        </p:blipFill>
         <p:spPr>
           <a:xfrm>
-            <a:off x="548640" y="365760"/>
-            <a:ext cx="11064240" cy="6035040"/>
+            <a:off x="0" y="0"/>
+            <a:ext cx="12191695" cy="6858000"/>
           </a:xfrm>
           <a:prstGeom prst="rect">
             <a:avLst/>
           </a:prstGeom>
-          <a:noFill/>
         </p:spPr>
-        <p:txBody>
-          <a:bodyPr wrap="square">
-            <a:spAutoFit/>
-          </a:bodyPr>
-          <a:lstStyle/>
-          <a:p>
-            <a:r>
-              <a:rPr sz="4000" b="1"/>
-              <a:t>AMD Radeon / ROCm Optimization</a:t>
-            </a:r>
-          </a:p>
-          <a:p>
-            <a:pPr>
-              <a:spcAft>
-                <a:spcPts val="1000"/>
-              </a:spcAft>
-              <a:defRPr sz="2000"/>
-            </a:pPr>
-            <a:r>
-              <a:t>Single AMD Radeon gfx1100, 48 GB VRAM, ROCm 7.2.x, vLLM 0.16.1</a:t>
-            </a:r>
-          </a:p>
-          <a:p>
-            <a:pPr>
-              <a:spcAft>
-                <a:spcPts val="1000"/>
-              </a:spcAft>
-              <a:defRPr sz="2000"/>
-            </a:pPr>
-            <a:r>
-              <a:t>AWQ 4-bit: 2.1x faster than bf16, halves VRAM (26.4 vs 12.3 tok/s)</a:t>
-            </a:r>
-          </a:p>
-          <a:p>
-            <a:pPr>
-              <a:spcAft>
-                <a:spcPts val="1000"/>
-              </a:spcAft>
-              <a:defRPr sz="2000"/>
-            </a:pPr>
-            <a:r>
-              <a:t>Dual-model co-residency: 14B + 32B on one card (42 GB, zero degradation)</a:t>
-            </a:r>
-          </a:p>
-          <a:p>
-            <a:pPr>
-              <a:spcAft>
-                <a:spcPts val="1000"/>
-              </a:spcAft>
-              <a:defRPr sz="2000"/>
-            </a:pPr>
-            <a:r>
-              <a:t>Context budgeting: 32B=4096, 14B=8192 (VRAM-aware)</a:t>
-            </a:r>
-          </a:p>
-          <a:p>
-            <a:pPr>
-              <a:spcAft>
-                <a:spcPts val="1000"/>
-              </a:spcAft>
-              <a:defRPr sz="2000"/>
-            </a:pPr>
-            <a:r>
-              <a:t>100% local inference — no cloud, no external API</a:t>
-            </a:r>
-          </a:p>
-        </p:txBody>
-      </p:sp>
+      </p:pic>
     </p:spTree>
   </p:cSld>
   <p:clrMapOvr>
@@ -3387,90 +3221,30 @@
         <p:nvPr/>
       </p:nvGrpSpPr>
       <p:grpSpPr/>
-      <p:sp>
-        <p:nvSpPr>
-          <p:cNvPr id="2" name="TextBox 1"/>
-          <p:cNvSpPr txBox="1"/>
+      <p:pic>
+        <p:nvPicPr>
+          <p:cNvPr id="2" name="Picture 1" descr="slide-4.png"/>
+          <p:cNvPicPr>
+            <a:picLocks noChangeAspect="1"/>
+          </p:cNvPicPr>
           <p:nvPr/>
-        </p:nvSpPr>
+        </p:nvPicPr>
+        <p:blipFill>
+          <a:blip r:embed="rId2"/>
+          <a:stretch>
+            <a:fillRect/>
+          </a:stretch>
+        </p:blipFill>
         <p:spPr>
           <a:xfrm>
-            <a:off x="548640" y="365760"/>
-            <a:ext cx="11064240" cy="6035040"/>
+            <a:off x="0" y="0"/>
+            <a:ext cx="12191695" cy="6858000"/>
           </a:xfrm>
           <a:prstGeom prst="rect">
             <a:avLst/>
           </a:prstGeom>
-          <a:noFill/>
         </p:spPr>
-        <p:txBody>
-          <a:bodyPr wrap="square">
-            <a:spAutoFit/>
-          </a:bodyPr>
-          <a:lstStyle/>
-          <a:p>
-            <a:r>
-              <a:rPr sz="4000" b="1"/>
-              <a:t>System Architecture</a:t>
-            </a:r>
-          </a:p>
-          <a:p>
-            <a:pPr>
-              <a:spcAft>
-                <a:spcPts val="1000"/>
-              </a:spcAft>
-              <a:defRPr sz="2000"/>
-            </a:pPr>
-            <a:r>
-              <a:t>React Web UI (SPA) → FastAPI → async extraction worker → SQLite</a:t>
-            </a:r>
-          </a:p>
-          <a:p>
-            <a:pPr>
-              <a:spcAft>
-                <a:spcPts val="1000"/>
-              </a:spcAft>
-              <a:defRPr sz="2000"/>
-            </a:pPr>
-            <a:r>
-              <a:t>Dialogue layer: Qwen2.5-14B-Instruct-AWQ (:8000, 26.5 tok/s)</a:t>
-            </a:r>
-          </a:p>
-          <a:p>
-            <a:pPr>
-              <a:spcAft>
-                <a:spcPts val="1000"/>
-              </a:spcAft>
-              <a:defRPr sz="2000"/>
-            </a:pPr>
-            <a:r>
-              <a:t>Batch layer: Qwen2.5-32B-Instruct-AWQ (:8001, 12.5 tok/s)</a:t>
-            </a:r>
-          </a:p>
-          <a:p>
-            <a:pPr>
-              <a:spcAft>
-                <a:spcPts val="1000"/>
-              </a:spcAft>
-              <a:defRPr sz="2000"/>
-            </a:pPr>
-            <a:r>
-              <a:t>Embedding: bge-base-en-v1.5 (RAG source grounding)</a:t>
-            </a:r>
-          </a:p>
-          <a:p>
-            <a:pPr>
-              <a:spcAft>
-                <a:spcPts val="1000"/>
-              </a:spcAft>
-              <a:defRPr sz="2000"/>
-            </a:pPr>
-            <a:r>
-              <a:t>Model routing validated by offline A/B (Qwen2.5 over Qwen3)</a:t>
-            </a:r>
-          </a:p>
-        </p:txBody>
-      </p:sp>
+      </p:pic>
     </p:spTree>
   </p:cSld>
   <p:clrMapOvr>
@@ -3489,79 +3263,156 @@
         <p:nvPr/>
       </p:nvGrpSpPr>
       <p:grpSpPr/>
-      <p:sp>
-        <p:nvSpPr>
-          <p:cNvPr id="2" name="TextBox 1"/>
-          <p:cNvSpPr txBox="1"/>
+      <p:pic>
+        <p:nvPicPr>
+          <p:cNvPr id="2" name="Picture 1" descr="slide-5.png"/>
+          <p:cNvPicPr>
+            <a:picLocks noChangeAspect="1"/>
+          </p:cNvPicPr>
           <p:nvPr/>
-        </p:nvSpPr>
+        </p:nvPicPr>
+        <p:blipFill>
+          <a:blip r:embed="rId2"/>
+          <a:stretch>
+            <a:fillRect/>
+          </a:stretch>
+        </p:blipFill>
         <p:spPr>
           <a:xfrm>
-            <a:off x="548640" y="365760"/>
-            <a:ext cx="11064240" cy="6035040"/>
+            <a:off x="0" y="0"/>
+            <a:ext cx="12191695" cy="6858000"/>
           </a:xfrm>
           <a:prstGeom prst="rect">
             <a:avLst/>
           </a:prstGeom>
-          <a:noFill/>
         </p:spPr>
-        <p:txBody>
-          <a:bodyPr wrap="square">
-            <a:spAutoFit/>
-          </a:bodyPr>
-          <a:lstStyle/>
-          <a:p>
-            <a:r>
-              <a:rPr sz="4000" b="1"/>
-              <a:t>Quality &amp; Testing</a:t>
-            </a:r>
-          </a:p>
-          <a:p>
-            <a:pPr>
-              <a:spcAft>
-                <a:spcPts val="1000"/>
-              </a:spcAft>
-              <a:defRPr sz="2000"/>
-            </a:pPr>
-            <a:r>
-              <a:t>85 backend unit tests (extraction, validation, study, review, drain)</a:t>
-            </a:r>
-          </a:p>
-          <a:p>
-            <a:pPr>
-              <a:spcAft>
-                <a:spcPts val="1000"/>
-              </a:spcAft>
-              <a:defRPr sz="2000"/>
-            </a:pPr>
-            <a:r>
-              <a:t>75 Playwright e2e tests across 3 viewports (375/768/1280)</a:t>
-            </a:r>
-          </a:p>
-          <a:p>
-            <a:pPr>
-              <a:spcAft>
-                <a:spcPts val="1000"/>
-              </a:spcAft>
-              <a:defRPr sz="2000"/>
-            </a:pPr>
-            <a:r>
-              <a:t>Contract parity gate: OpenAPI snapshot ↔ TypeScript types</a:t>
-            </a:r>
-          </a:p>
-          <a:p>
-            <a:pPr>
-              <a:spcAft>
-                <a:spcPts val="1000"/>
-              </a:spcAft>
-              <a:defRPr sz="2000"/>
-            </a:pPr>
-            <a:r>
-              <a:t>Demo video: 4:18 walkthrough with English narration + subtitles</a:t>
-            </a:r>
-          </a:p>
-        </p:txBody>
-      </p:sp>
+      </p:pic>
+    </p:spTree>
+  </p:cSld>
+  <p:clrMapOvr>
+    <a:masterClrMapping/>
+  </p:clrMapOvr>
+</p:sld>
+</file>
+
+<file path=ppt/slides/slide6.xml><?xml version="1.0" encoding="utf-8"?>
+<p:sld xmlns:a="http://schemas.openxmlformats.org/drawingml/2006/main" xmlns:p="http://schemas.openxmlformats.org/presentationml/2006/main" xmlns:r="http://schemas.openxmlformats.org/officeDocument/2006/relationships">
+  <p:cSld>
+    <p:spTree>
+      <p:nvGrpSpPr>
+        <p:cNvPr id="1" name=""/>
+        <p:cNvGrpSpPr/>
+        <p:nvPr/>
+      </p:nvGrpSpPr>
+      <p:grpSpPr/>
+      <p:pic>
+        <p:nvPicPr>
+          <p:cNvPr id="2" name="Picture 1" descr="slide-6.png"/>
+          <p:cNvPicPr>
+            <a:picLocks noChangeAspect="1"/>
+          </p:cNvPicPr>
+          <p:nvPr/>
+        </p:nvPicPr>
+        <p:blipFill>
+          <a:blip r:embed="rId2"/>
+          <a:stretch>
+            <a:fillRect/>
+          </a:stretch>
+        </p:blipFill>
+        <p:spPr>
+          <a:xfrm>
+            <a:off x="0" y="0"/>
+            <a:ext cx="12191695" cy="6858000"/>
+          </a:xfrm>
+          <a:prstGeom prst="rect">
+            <a:avLst/>
+          </a:prstGeom>
+        </p:spPr>
+      </p:pic>
+    </p:spTree>
+  </p:cSld>
+  <p:clrMapOvr>
+    <a:masterClrMapping/>
+  </p:clrMapOvr>
+</p:sld>
+</file>
+
+<file path=ppt/slides/slide7.xml><?xml version="1.0" encoding="utf-8"?>
+<p:sld xmlns:a="http://schemas.openxmlformats.org/drawingml/2006/main" xmlns:p="http://schemas.openxmlformats.org/presentationml/2006/main" xmlns:r="http://schemas.openxmlformats.org/officeDocument/2006/relationships">
+  <p:cSld>
+    <p:spTree>
+      <p:nvGrpSpPr>
+        <p:cNvPr id="1" name=""/>
+        <p:cNvGrpSpPr/>
+        <p:nvPr/>
+      </p:nvGrpSpPr>
+      <p:grpSpPr/>
+      <p:pic>
+        <p:nvPicPr>
+          <p:cNvPr id="2" name="Picture 1" descr="slide-7.png"/>
+          <p:cNvPicPr>
+            <a:picLocks noChangeAspect="1"/>
+          </p:cNvPicPr>
+          <p:nvPr/>
+        </p:nvPicPr>
+        <p:blipFill>
+          <a:blip r:embed="rId2"/>
+          <a:stretch>
+            <a:fillRect/>
+          </a:stretch>
+        </p:blipFill>
+        <p:spPr>
+          <a:xfrm>
+            <a:off x="0" y="0"/>
+            <a:ext cx="12191695" cy="6858000"/>
+          </a:xfrm>
+          <a:prstGeom prst="rect">
+            <a:avLst/>
+          </a:prstGeom>
+        </p:spPr>
+      </p:pic>
+    </p:spTree>
+  </p:cSld>
+  <p:clrMapOvr>
+    <a:masterClrMapping/>
+  </p:clrMapOvr>
+</p:sld>
+</file>
+
+<file path=ppt/slides/slide8.xml><?xml version="1.0" encoding="utf-8"?>
+<p:sld xmlns:a="http://schemas.openxmlformats.org/drawingml/2006/main" xmlns:p="http://schemas.openxmlformats.org/presentationml/2006/main" xmlns:r="http://schemas.openxmlformats.org/officeDocument/2006/relationships">
+  <p:cSld>
+    <p:spTree>
+      <p:nvGrpSpPr>
+        <p:cNvPr id="1" name=""/>
+        <p:cNvGrpSpPr/>
+        <p:nvPr/>
+      </p:nvGrpSpPr>
+      <p:grpSpPr/>
+      <p:pic>
+        <p:nvPicPr>
+          <p:cNvPr id="2" name="Picture 1" descr="slide-8.png"/>
+          <p:cNvPicPr>
+            <a:picLocks noChangeAspect="1"/>
+          </p:cNvPicPr>
+          <p:nvPr/>
+        </p:nvPicPr>
+        <p:blipFill>
+          <a:blip r:embed="rId2"/>
+          <a:stretch>
+            <a:fillRect/>
+          </a:stretch>
+        </p:blipFill>
+        <p:spPr>
+          <a:xfrm>
+            <a:off x="0" y="0"/>
+            <a:ext cx="12191695" cy="6858000"/>
+          </a:xfrm>
+          <a:prstGeom prst="rect">
+            <a:avLst/>
+          </a:prstGeom>
+        </p:spPr>
+      </p:pic>
     </p:spTree>
   </p:cSld>
   <p:clrMapOvr>

</xml_diff>